<commit_message>
lecture ready(0818) : react_TS pptx.
</commit_message>
<xml_diff>
--- a/material/[SeSAC_YDP_6] 32_TypeScript.pptx
+++ b/material/[SeSAC_YDP_6] 32_TypeScript.pptx
@@ -2,7 +2,7 @@
 <file path=ppt/presentation.xml><?xml version="1.0" encoding="utf-8"?>
 <p:presentation xmlns:a="http://schemas.openxmlformats.org/drawingml/2006/main" xmlns:r="http://schemas.openxmlformats.org/officeDocument/2006/relationships" xmlns:p="http://schemas.openxmlformats.org/presentationml/2006/main" saveSubsetFonts="1">
   <p:sldMasterIdLst>
-    <p:sldMasterId id="2147483660" r:id="rId1"/>
+    <p:sldMasterId id="2147483673" r:id="rId1"/>
   </p:sldMasterIdLst>
   <p:notesMasterIdLst>
     <p:notesMasterId r:id="rId39"/>
@@ -236,7 +236,7 @@
           <a:p>
             <a:fld id="{86F0F02C-F923-483B-B7AF-E4D1E093BA0E}" type="datetimeFigureOut">
               <a:rPr lang="ko-KR" altLang="en-US" smtClean="0"/>
-              <a:t>2023-10-10</a:t>
+              <a:t>2024-08-19</a:t>
             </a:fld>
             <a:endParaRPr lang="ko-KR" altLang="en-US"/>
           </a:p>
@@ -1545,8 +1545,26 @@
           <a:lstStyle/>
           <a:p>
             <a:r>
+              <a:rPr lang="en-US" altLang="ko-KR" i="0" dirty="0" smtClean="0"/>
+              <a:t>** </a:t>
+            </a:r>
+            <a:r>
+              <a:rPr lang="en-US" altLang="ko-KR" i="0" dirty="0" err="1" smtClean="0"/>
+              <a:t>TypeScript</a:t>
+            </a:r>
+            <a:r>
+              <a:rPr lang="en-US" altLang="ko-KR" i="0" dirty="0" smtClean="0"/>
+              <a:t>?</a:t>
+            </a:r>
+          </a:p>
+          <a:p>
+            <a:r>
+              <a:rPr lang="ko-KR" altLang="en-US" i="0" dirty="0" smtClean="0"/>
+              <a:t>타입이 </a:t>
+            </a:r>
+            <a:r>
               <a:rPr lang="ko-KR" altLang="en-US" i="0" dirty="0"/>
-              <a:t>타입이 있는</a:t>
+              <a:t>있는</a:t>
             </a:r>
             <a:r>
               <a:rPr lang="en-US" altLang="ko-KR" i="0" dirty="0"/>
@@ -1558,7 +1576,43 @@
             </a:r>
             <a:r>
               <a:rPr lang="en-US" altLang="ko-KR" i="0" dirty="0"/>
-              <a:t>(superset)</a:t>
+              <a:t>(superset</a:t>
+            </a:r>
+            <a:r>
+              <a:rPr lang="en-US" altLang="ko-KR" i="0" dirty="0" smtClean="0"/>
+              <a:t>)</a:t>
+            </a:r>
+          </a:p>
+          <a:p>
+            <a:r>
+              <a:rPr lang="en-US" altLang="ko-KR" dirty="0" smtClean="0"/>
+              <a:t>JavaScript</a:t>
+            </a:r>
+            <a:r>
+              <a:rPr lang="ko-KR" altLang="en-US" dirty="0" smtClean="0"/>
+              <a:t>에 정적 타입을 추가한 언어</a:t>
+            </a:r>
+            <a:endParaRPr lang="en-US" altLang="ko-KR" i="0" dirty="0" smtClean="0"/>
+          </a:p>
+          <a:p>
+            <a:endParaRPr lang="en-US" altLang="ko-KR" i="0" dirty="0" smtClean="0"/>
+          </a:p>
+          <a:p>
+            <a:r>
+              <a:rPr lang="en-US" altLang="ko-KR" dirty="0" err="1" smtClean="0"/>
+              <a:t>TypeScript</a:t>
+            </a:r>
+            <a:r>
+              <a:rPr lang="ko-KR" altLang="en-US" dirty="0" smtClean="0"/>
+              <a:t>를 처음 접하는 개발자들에게 </a:t>
+            </a:r>
+            <a:r>
+              <a:rPr lang="en-US" altLang="ko-KR" dirty="0" err="1" smtClean="0"/>
+              <a:t>TypeScript</a:t>
+            </a:r>
+            <a:r>
+              <a:rPr lang="ko-KR" altLang="en-US" dirty="0" smtClean="0"/>
+              <a:t>의 기본 개념과 기능을 소개하는 데 초점을 맞춘 가이드</a:t>
             </a:r>
             <a:endParaRPr lang="ko-KR" altLang="en-US" i="0" dirty="0"/>
           </a:p>
@@ -1812,6 +1866,148 @@
           <a:bodyPr/>
           <a:lstStyle/>
           <a:p>
+            <a:r>
+              <a:rPr lang="en-US" altLang="ko-KR" dirty="0" smtClean="0"/>
+              <a:t>**</a:t>
+            </a:r>
+            <a:r>
+              <a:rPr lang="ko-KR" altLang="en-US" dirty="0" smtClean="0"/>
+              <a:t>정적 타입 언어</a:t>
+            </a:r>
+            <a:endParaRPr lang="en-US" altLang="ko-KR" dirty="0" smtClean="0"/>
+          </a:p>
+          <a:p>
+            <a:pPr marL="171450" indent="-171450">
+              <a:buFontTx/>
+              <a:buChar char="-"/>
+            </a:pPr>
+            <a:r>
+              <a:rPr lang="ko-KR" altLang="en-US" b="1" dirty="0" smtClean="0"/>
+              <a:t>실행 전 타입 검사</a:t>
+            </a:r>
+            <a:r>
+              <a:rPr lang="en-US" altLang="ko-KR" dirty="0" smtClean="0"/>
+              <a:t>: </a:t>
+            </a:r>
+            <a:r>
+              <a:rPr lang="ko-KR" altLang="en-US" dirty="0" smtClean="0"/>
+              <a:t>정적 타입 언어에서는 코드가 실행되기 전에 타입 검사와 오류 검출이 이루어집니다</a:t>
+            </a:r>
+            <a:r>
+              <a:rPr lang="en-US" altLang="ko-KR" dirty="0" smtClean="0"/>
+              <a:t>. </a:t>
+            </a:r>
+          </a:p>
+          <a:p>
+            <a:pPr marL="171450" indent="-171450">
+              <a:buFontTx/>
+              <a:buChar char="-"/>
+            </a:pPr>
+            <a:r>
+              <a:rPr lang="ko-KR" altLang="en-US" dirty="0" smtClean="0"/>
+              <a:t>이는 코드가 실행되기 전에 타입 관련 오류를 발견할 수 있도록 도와줍니다</a:t>
+            </a:r>
+            <a:r>
+              <a:rPr lang="en-US" altLang="ko-KR" dirty="0" smtClean="0"/>
+              <a:t>.</a:t>
+            </a:r>
+          </a:p>
+          <a:p>
+            <a:pPr marL="171450" indent="-171450">
+              <a:buFontTx/>
+              <a:buChar char="-"/>
+            </a:pPr>
+            <a:r>
+              <a:rPr lang="en-US" altLang="ko-KR" dirty="0" smtClean="0"/>
+              <a:t> </a:t>
+            </a:r>
+            <a:r>
+              <a:rPr lang="ko-KR" altLang="en-US" dirty="0" smtClean="0"/>
+              <a:t>예를 들어</a:t>
+            </a:r>
+            <a:r>
+              <a:rPr lang="en-US" altLang="ko-KR" dirty="0" smtClean="0"/>
+              <a:t>, </a:t>
+            </a:r>
+            <a:r>
+              <a:rPr lang="en-US" altLang="ko-KR" dirty="0" err="1" smtClean="0"/>
+              <a:t>TypeScript</a:t>
+            </a:r>
+            <a:r>
+              <a:rPr lang="ko-KR" altLang="en-US" dirty="0" smtClean="0"/>
+              <a:t>와 같은 언어는 코드 작성 시 타입 오류를 검출하여 컴파일 타임에 수정할 수 있게 합니다</a:t>
+            </a:r>
+            <a:r>
+              <a:rPr lang="en-US" altLang="ko-KR" dirty="0" smtClean="0"/>
+              <a:t>.</a:t>
+            </a:r>
+          </a:p>
+          <a:p>
+            <a:pPr marL="171450" indent="-171450">
+              <a:buFontTx/>
+              <a:buChar char="-"/>
+            </a:pPr>
+            <a:endParaRPr lang="en-US" altLang="ko-KR" dirty="0" smtClean="0"/>
+          </a:p>
+          <a:p>
+            <a:r>
+              <a:rPr lang="ko-KR" altLang="en-US" b="1" dirty="0" smtClean="0"/>
+              <a:t>컴파일 타임 타입 검사</a:t>
+            </a:r>
+          </a:p>
+          <a:p>
+            <a:r>
+              <a:rPr lang="ko-KR" altLang="en-US" b="1" dirty="0" smtClean="0"/>
+              <a:t>오류 조기 발견</a:t>
+            </a:r>
+            <a:r>
+              <a:rPr lang="en-US" altLang="ko-KR" dirty="0" smtClean="0"/>
+              <a:t>: </a:t>
+            </a:r>
+            <a:r>
+              <a:rPr lang="ko-KR" altLang="en-US" dirty="0" smtClean="0"/>
+              <a:t>코드가 실행되기 전에 타입 검사를 수행하므로</a:t>
+            </a:r>
+            <a:r>
+              <a:rPr lang="en-US" altLang="ko-KR" dirty="0" smtClean="0"/>
+              <a:t>, </a:t>
+            </a:r>
+            <a:r>
+              <a:rPr lang="ko-KR" altLang="en-US" dirty="0" smtClean="0"/>
+              <a:t>런타임에 발생할 수 있는 타입 관련 오류를 사전에 발견하고 수정할 수 있습니다</a:t>
+            </a:r>
+            <a:r>
+              <a:rPr lang="en-US" altLang="ko-KR" dirty="0" smtClean="0"/>
+              <a:t>. </a:t>
+            </a:r>
+          </a:p>
+          <a:p>
+            <a:r>
+              <a:rPr lang="ko-KR" altLang="en-US" dirty="0" smtClean="0"/>
+              <a:t>예를 들어</a:t>
+            </a:r>
+            <a:r>
+              <a:rPr lang="en-US" altLang="ko-KR" dirty="0" smtClean="0"/>
+              <a:t>, </a:t>
+            </a:r>
+            <a:r>
+              <a:rPr lang="en-US" altLang="ko-KR" dirty="0" err="1" smtClean="0"/>
+              <a:t>TypeScript</a:t>
+            </a:r>
+            <a:r>
+              <a:rPr lang="ko-KR" altLang="en-US" dirty="0" smtClean="0"/>
+              <a:t>에서는 변수나 함수의 타입이 잘못 사용되면 컴파일 시점에서 오류를 발생시킵니다</a:t>
+            </a:r>
+            <a:r>
+              <a:rPr lang="en-US" altLang="ko-KR" dirty="0" smtClean="0"/>
+              <a:t>.</a:t>
+            </a:r>
+          </a:p>
+          <a:p>
+            <a:pPr marL="171450" indent="-171450">
+              <a:buFontTx/>
+              <a:buChar char="-"/>
+            </a:pPr>
             <a:endParaRPr lang="ko-KR" altLang="en-US" dirty="0"/>
           </a:p>
         </p:txBody>
@@ -2404,6 +2600,32 @@
           <a:bodyPr/>
           <a:lstStyle/>
           <a:p>
+            <a:r>
+              <a:rPr lang="en-US" altLang="ko-KR" dirty="0" smtClean="0"/>
+              <a:t>**</a:t>
+            </a:r>
+            <a:r>
+              <a:rPr lang="en-US" altLang="ko-KR" baseline="0" dirty="0" smtClean="0"/>
+              <a:t> </a:t>
+            </a:r>
+            <a:r>
+              <a:rPr lang="en-US" altLang="ko-KR" baseline="0" dirty="0" err="1" smtClean="0"/>
+              <a:t>ts</a:t>
+            </a:r>
+            <a:r>
+              <a:rPr lang="en-US" altLang="ko-KR" baseline="0" dirty="0" smtClean="0"/>
+              <a:t>-node</a:t>
+            </a:r>
+          </a:p>
+          <a:p>
+            <a:r>
+              <a:rPr lang="en-US" altLang="ko-KR" baseline="0" dirty="0" smtClean="0"/>
+              <a:t>- TS</a:t>
+            </a:r>
+            <a:r>
+              <a:rPr lang="ko-KR" altLang="en-US" baseline="0" dirty="0" smtClean="0"/>
+              <a:t>파일을 직접 실행 할 수 있게 해주는 도구</a:t>
+            </a:r>
             <a:endParaRPr lang="ko-KR" altLang="en-US" dirty="0"/>
           </a:p>
         </p:txBody>
@@ -2545,43 +2767,6 @@
           <a:chExt cx="0" cy="0"/>
         </a:xfrm>
       </p:grpSpPr>
-      <p:pic>
-        <p:nvPicPr>
-          <p:cNvPr id="7" name="그림 6" descr="폰트, 텍스트, 로고, 그래픽이(가) 표시된 사진&#10;&#10;자동 생성된 설명">
-            <a:extLst>
-              <a:ext uri="{FF2B5EF4-FFF2-40B4-BE49-F238E27FC236}">
-                <a16:creationId xmlns:a16="http://schemas.microsoft.com/office/drawing/2014/main" id="{01AB1409-DEDF-C824-D8D3-05B260A93BD6}"/>
-              </a:ext>
-            </a:extLst>
-          </p:cNvPr>
-          <p:cNvPicPr>
-            <a:picLocks noChangeAspect="1"/>
-          </p:cNvPicPr>
-          <p:nvPr userDrawn="1"/>
-        </p:nvPicPr>
-        <p:blipFill>
-          <a:blip r:embed="rId2">
-            <a:alphaModFix/>
-            <a:extLst>
-              <a:ext uri="{28A0092B-C50C-407E-A947-70E740481C1C}">
-                <a14:useLocalDpi xmlns:a14="http://schemas.microsoft.com/office/drawing/2010/main" val="0"/>
-              </a:ext>
-            </a:extLst>
-          </a:blip>
-          <a:stretch>
-            <a:fillRect/>
-          </a:stretch>
-        </p:blipFill>
-        <p:spPr>
-          <a:xfrm>
-            <a:off x="118533" y="103811"/>
-            <a:ext cx="4328535" cy="2280805"/>
-          </a:xfrm>
-          <a:prstGeom prst="rect">
-            <a:avLst/>
-          </a:prstGeom>
-        </p:spPr>
-      </p:pic>
       <p:sp>
         <p:nvSpPr>
           <p:cNvPr id="2" name="제목 1">
@@ -2719,7 +2904,7 @@
           <a:p>
             <a:fld id="{0E19CB95-6D28-40F1-9DA3-1BAC5D4B5B4F}" type="datetime6">
               <a:rPr lang="ko-KR" altLang="en-US" smtClean="0"/>
-              <a:t>2023년 10월</a:t>
+              <a:t>2024년 8월</a:t>
             </a:fld>
             <a:endParaRPr lang="ko-KR" altLang="en-US"/>
           </a:p>
@@ -2834,221 +3019,47 @@
           </a:p>
         </p:txBody>
       </p:sp>
-      <p:sp>
-        <p:nvSpPr>
-          <p:cNvPr id="15" name="부제목 2">
+      <p:pic>
+        <p:nvPicPr>
+          <p:cNvPr id="5" name="그림 4" descr="그래픽, 그래픽 디자인, 클립아트, 다채로움이(가) 표시된 사진&#10;&#10;자동 생성된 설명">
             <a:extLst>
               <a:ext uri="{FF2B5EF4-FFF2-40B4-BE49-F238E27FC236}">
-                <a16:creationId xmlns:a16="http://schemas.microsoft.com/office/drawing/2014/main" id="{26026682-DE15-5F01-6FA7-8F46F9ABCC2A}"/>
+                <a16:creationId xmlns:a16="http://schemas.microsoft.com/office/drawing/2014/main" id="{BE5A577B-81A7-2FA6-9E57-9DCEC5BF71F7}"/>
               </a:ext>
             </a:extLst>
           </p:cNvPr>
-          <p:cNvSpPr txBox="1">
-            <a:spLocks/>
-          </p:cNvSpPr>
+          <p:cNvPicPr>
+            <a:picLocks noChangeAspect="1"/>
+          </p:cNvPicPr>
           <p:nvPr userDrawn="1"/>
-        </p:nvSpPr>
+        </p:nvPicPr>
+        <p:blipFill>
+          <a:blip r:embed="rId2" cstate="hqprint">
+            <a:alphaModFix amt="20000"/>
+            <a:extLst>
+              <a:ext uri="{28A0092B-C50C-407E-A947-70E740481C1C}">
+                <a14:useLocalDpi xmlns:a14="http://schemas.microsoft.com/office/drawing/2010/main" val="0"/>
+              </a:ext>
+            </a:extLst>
+          </a:blip>
+          <a:stretch>
+            <a:fillRect/>
+          </a:stretch>
+        </p:blipFill>
         <p:spPr>
           <a:xfrm>
-            <a:off x="9110749" y="5933035"/>
-            <a:ext cx="2948515" cy="365125"/>
+            <a:off x="4296000" y="1461146"/>
+            <a:ext cx="3600000" cy="3652155"/>
           </a:xfrm>
           <a:prstGeom prst="rect">
             <a:avLst/>
           </a:prstGeom>
         </p:spPr>
-        <p:txBody>
-          <a:bodyPr vert="horz" lIns="91440" tIns="45720" rIns="91440" bIns="45720" rtlCol="0" anchor="ctr">
-            <a:noAutofit/>
-          </a:bodyPr>
-          <a:lstStyle>
-            <a:lvl1pPr marL="228600" indent="-228600" algn="l" defTabSz="914400" rtl="0" eaLnBrk="1" latinLnBrk="1" hangingPunct="1">
-              <a:lnSpc>
-                <a:spcPct val="90000"/>
-              </a:lnSpc>
-              <a:spcBef>
-                <a:spcPts val="1000"/>
-              </a:spcBef>
-              <a:buFont typeface="Arial" panose="020B0604020202020204" pitchFamily="34" charset="0"/>
-              <a:buChar char="•"/>
-              <a:defRPr sz="2800" kern="1200">
-                <a:solidFill>
-                  <a:schemeClr val="tx1"/>
-                </a:solidFill>
-                <a:latin typeface="+mn-lt"/>
-                <a:ea typeface="+mn-ea"/>
-                <a:cs typeface="+mn-cs"/>
-              </a:defRPr>
-            </a:lvl1pPr>
-            <a:lvl2pPr marL="685800" indent="-228600" algn="l" defTabSz="914400" rtl="0" eaLnBrk="1" latinLnBrk="1" hangingPunct="1">
-              <a:lnSpc>
-                <a:spcPct val="90000"/>
-              </a:lnSpc>
-              <a:spcBef>
-                <a:spcPts val="500"/>
-              </a:spcBef>
-              <a:buFont typeface="Arial" panose="020B0604020202020204" pitchFamily="34" charset="0"/>
-              <a:buChar char="•"/>
-              <a:defRPr sz="2400" kern="1200">
-                <a:solidFill>
-                  <a:schemeClr val="tx1"/>
-                </a:solidFill>
-                <a:latin typeface="+mn-lt"/>
-                <a:ea typeface="+mn-ea"/>
-                <a:cs typeface="+mn-cs"/>
-              </a:defRPr>
-            </a:lvl2pPr>
-            <a:lvl3pPr marL="1143000" indent="-228600" algn="l" defTabSz="914400" rtl="0" eaLnBrk="1" latinLnBrk="1" hangingPunct="1">
-              <a:lnSpc>
-                <a:spcPct val="90000"/>
-              </a:lnSpc>
-              <a:spcBef>
-                <a:spcPts val="500"/>
-              </a:spcBef>
-              <a:buFont typeface="Arial" panose="020B0604020202020204" pitchFamily="34" charset="0"/>
-              <a:buChar char="•"/>
-              <a:defRPr sz="2000" kern="1200">
-                <a:solidFill>
-                  <a:schemeClr val="tx1"/>
-                </a:solidFill>
-                <a:latin typeface="+mn-lt"/>
-                <a:ea typeface="+mn-ea"/>
-                <a:cs typeface="+mn-cs"/>
-              </a:defRPr>
-            </a:lvl3pPr>
-            <a:lvl4pPr marL="1600200" indent="-228600" algn="l" defTabSz="914400" rtl="0" eaLnBrk="1" latinLnBrk="1" hangingPunct="1">
-              <a:lnSpc>
-                <a:spcPct val="90000"/>
-              </a:lnSpc>
-              <a:spcBef>
-                <a:spcPts val="500"/>
-              </a:spcBef>
-              <a:buFont typeface="Arial" panose="020B0604020202020204" pitchFamily="34" charset="0"/>
-              <a:buChar char="•"/>
-              <a:defRPr sz="1800" kern="1200">
-                <a:solidFill>
-                  <a:schemeClr val="tx1"/>
-                </a:solidFill>
-                <a:latin typeface="+mn-lt"/>
-                <a:ea typeface="+mn-ea"/>
-                <a:cs typeface="+mn-cs"/>
-              </a:defRPr>
-            </a:lvl4pPr>
-            <a:lvl5pPr marL="2057400" indent="-228600" algn="l" defTabSz="914400" rtl="0" eaLnBrk="1" latinLnBrk="1" hangingPunct="1">
-              <a:lnSpc>
-                <a:spcPct val="90000"/>
-              </a:lnSpc>
-              <a:spcBef>
-                <a:spcPts val="500"/>
-              </a:spcBef>
-              <a:buFont typeface="Arial" panose="020B0604020202020204" pitchFamily="34" charset="0"/>
-              <a:buChar char="•"/>
-              <a:defRPr sz="1800" kern="1200">
-                <a:solidFill>
-                  <a:schemeClr val="tx1"/>
-                </a:solidFill>
-                <a:latin typeface="+mn-lt"/>
-                <a:ea typeface="+mn-ea"/>
-                <a:cs typeface="+mn-cs"/>
-              </a:defRPr>
-            </a:lvl5pPr>
-            <a:lvl6pPr marL="2514600" indent="-228600" algn="l" defTabSz="914400" rtl="0" eaLnBrk="1" latinLnBrk="1" hangingPunct="1">
-              <a:lnSpc>
-                <a:spcPct val="90000"/>
-              </a:lnSpc>
-              <a:spcBef>
-                <a:spcPts val="500"/>
-              </a:spcBef>
-              <a:buFont typeface="Arial" panose="020B0604020202020204" pitchFamily="34" charset="0"/>
-              <a:buChar char="•"/>
-              <a:defRPr sz="1800" kern="1200">
-                <a:solidFill>
-                  <a:schemeClr val="tx1"/>
-                </a:solidFill>
-                <a:latin typeface="+mn-lt"/>
-                <a:ea typeface="+mn-ea"/>
-                <a:cs typeface="+mn-cs"/>
-              </a:defRPr>
-            </a:lvl6pPr>
-            <a:lvl7pPr marL="2971800" indent="-228600" algn="l" defTabSz="914400" rtl="0" eaLnBrk="1" latinLnBrk="1" hangingPunct="1">
-              <a:lnSpc>
-                <a:spcPct val="90000"/>
-              </a:lnSpc>
-              <a:spcBef>
-                <a:spcPts val="500"/>
-              </a:spcBef>
-              <a:buFont typeface="Arial" panose="020B0604020202020204" pitchFamily="34" charset="0"/>
-              <a:buChar char="•"/>
-              <a:defRPr sz="1800" kern="1200">
-                <a:solidFill>
-                  <a:schemeClr val="tx1"/>
-                </a:solidFill>
-                <a:latin typeface="+mn-lt"/>
-                <a:ea typeface="+mn-ea"/>
-                <a:cs typeface="+mn-cs"/>
-              </a:defRPr>
-            </a:lvl7pPr>
-            <a:lvl8pPr marL="3429000" indent="-228600" algn="l" defTabSz="914400" rtl="0" eaLnBrk="1" latinLnBrk="1" hangingPunct="1">
-              <a:lnSpc>
-                <a:spcPct val="90000"/>
-              </a:lnSpc>
-              <a:spcBef>
-                <a:spcPts val="500"/>
-              </a:spcBef>
-              <a:buFont typeface="Arial" panose="020B0604020202020204" pitchFamily="34" charset="0"/>
-              <a:buChar char="•"/>
-              <a:defRPr sz="1800" kern="1200">
-                <a:solidFill>
-                  <a:schemeClr val="tx1"/>
-                </a:solidFill>
-                <a:latin typeface="+mn-lt"/>
-                <a:ea typeface="+mn-ea"/>
-                <a:cs typeface="+mn-cs"/>
-              </a:defRPr>
-            </a:lvl8pPr>
-            <a:lvl9pPr marL="3886200" indent="-228600" algn="l" defTabSz="914400" rtl="0" eaLnBrk="1" latinLnBrk="1" hangingPunct="1">
-              <a:lnSpc>
-                <a:spcPct val="90000"/>
-              </a:lnSpc>
-              <a:spcBef>
-                <a:spcPts val="500"/>
-              </a:spcBef>
-              <a:buFont typeface="Arial" panose="020B0604020202020204" pitchFamily="34" charset="0"/>
-              <a:buChar char="•"/>
-              <a:defRPr sz="1800" kern="1200">
-                <a:solidFill>
-                  <a:schemeClr val="tx1"/>
-                </a:solidFill>
-                <a:latin typeface="+mn-lt"/>
-                <a:ea typeface="+mn-ea"/>
-                <a:cs typeface="+mn-cs"/>
-              </a:defRPr>
-            </a:lvl9pPr>
-          </a:lstStyle>
-          <a:p>
-            <a:pPr marL="0" indent="0" algn="r">
-              <a:buNone/>
-            </a:pPr>
-            <a:r>
-              <a:rPr lang="en-US" altLang="ko-KR" sz="2000" u="none" dirty="0"/>
-              <a:t>With. </a:t>
-            </a:r>
-            <a:r>
-              <a:rPr lang="ko-KR" altLang="en-US" sz="2000" u="none" dirty="0"/>
-              <a:t>팀 </a:t>
-            </a:r>
-            <a:r>
-              <a:rPr lang="ko-KR" altLang="en-US" sz="2000" u="none" dirty="0" err="1"/>
-              <a:t>뤼쳐드</a:t>
-            </a:r>
-            <a:endParaRPr lang="ko-KR" altLang="en-US" sz="2000" u="none" dirty="0"/>
-          </a:p>
-        </p:txBody>
-      </p:sp>
+      </p:pic>
     </p:spTree>
     <p:extLst>
       <p:ext uri="{BB962C8B-B14F-4D97-AF65-F5344CB8AC3E}">
-        <p14:creationId xmlns:p14="http://schemas.microsoft.com/office/powerpoint/2010/main" val="4049132477"/>
+        <p14:creationId xmlns:p14="http://schemas.microsoft.com/office/powerpoint/2010/main" val="1435878751"/>
       </p:ext>
     </p:extLst>
   </p:cSld>
@@ -3101,12 +3112,12 @@
           <a:bodyPr anchor="b"/>
           <a:lstStyle>
             <a:lvl1pPr>
-              <a:defRPr sz="3200"/>
+              <a:defRPr sz="3200" b="1"/>
             </a:lvl1pPr>
           </a:lstStyle>
           <a:p>
             <a:r>
-              <a:rPr lang="ko-KR" altLang="en-US"/>
+              <a:rPr lang="ko-KR" altLang="en-US" dirty="0"/>
               <a:t>마스터 제목 스타일 편집</a:t>
             </a:r>
           </a:p>
@@ -3273,7 +3284,7 @@
           <a:p>
             <a:fld id="{C4A39A32-5728-48B8-9F9C-437D214CCAF1}" type="datetime6">
               <a:rPr lang="ko-KR" altLang="en-US" smtClean="0"/>
-              <a:t>2023년 10월</a:t>
+              <a:t>2024년 8월</a:t>
             </a:fld>
             <a:endParaRPr lang="ko-KR" altLang="en-US"/>
           </a:p>
@@ -3336,7 +3347,7 @@
     </p:spTree>
     <p:extLst>
       <p:ext uri="{BB962C8B-B14F-4D97-AF65-F5344CB8AC3E}">
-        <p14:creationId xmlns:p14="http://schemas.microsoft.com/office/powerpoint/2010/main" val="3082029487"/>
+        <p14:creationId xmlns:p14="http://schemas.microsoft.com/office/powerpoint/2010/main" val="795419455"/>
       </p:ext>
     </p:extLst>
   </p:cSld>
@@ -3382,10 +3393,14 @@
         <p:spPr/>
         <p:txBody>
           <a:bodyPr/>
-          <a:lstStyle/>
-          <a:p>
-            <a:r>
-              <a:rPr lang="ko-KR" altLang="en-US"/>
+          <a:lstStyle>
+            <a:lvl1pPr>
+              <a:defRPr b="1"/>
+            </a:lvl1pPr>
+          </a:lstStyle>
+          <a:p>
+            <a:r>
+              <a:rPr lang="ko-KR" altLang="en-US" dirty="0"/>
               <a:t>마스터 제목 스타일 편집</a:t>
             </a:r>
           </a:p>
@@ -3471,7 +3486,7 @@
           <a:p>
             <a:fld id="{3BECC8BA-EBCB-4BF9-8E87-970CE0138376}" type="datetime6">
               <a:rPr lang="ko-KR" altLang="en-US" smtClean="0"/>
-              <a:t>2023년 10월</a:t>
+              <a:t>2024년 8월</a:t>
             </a:fld>
             <a:endParaRPr lang="ko-KR" altLang="en-US"/>
           </a:p>
@@ -3534,7 +3549,7 @@
     </p:spTree>
     <p:extLst>
       <p:ext uri="{BB962C8B-B14F-4D97-AF65-F5344CB8AC3E}">
-        <p14:creationId xmlns:p14="http://schemas.microsoft.com/office/powerpoint/2010/main" val="1851563776"/>
+        <p14:creationId xmlns:p14="http://schemas.microsoft.com/office/powerpoint/2010/main" val="428192397"/>
       </p:ext>
     </p:extLst>
   </p:cSld>
@@ -3679,7 +3694,7 @@
           <a:p>
             <a:fld id="{7869FA6E-4699-4AC6-B2CB-4E60A58ED7A8}" type="datetime6">
               <a:rPr lang="ko-KR" altLang="en-US" smtClean="0"/>
-              <a:t>2023년 10월</a:t>
+              <a:t>2024년 8월</a:t>
             </a:fld>
             <a:endParaRPr lang="ko-KR" altLang="en-US"/>
           </a:p>
@@ -3742,7 +3757,7 @@
     </p:spTree>
     <p:extLst>
       <p:ext uri="{BB962C8B-B14F-4D97-AF65-F5344CB8AC3E}">
-        <p14:creationId xmlns:p14="http://schemas.microsoft.com/office/powerpoint/2010/main" val="376005128"/>
+        <p14:creationId xmlns:p14="http://schemas.microsoft.com/office/powerpoint/2010/main" val="3632072011"/>
       </p:ext>
     </p:extLst>
   </p:cSld>
@@ -3792,7 +3807,7 @@
           <a:p>
             <a:fld id="{0E19CB95-6D28-40F1-9DA3-1BAC5D4B5B4F}" type="datetime6">
               <a:rPr lang="ko-KR" altLang="en-US" smtClean="0"/>
-              <a:t>2023년 10월</a:t>
+              <a:t>2024년 8월</a:t>
             </a:fld>
             <a:endParaRPr lang="ko-KR" altLang="en-US"/>
           </a:p>
@@ -3929,7 +3944,7 @@
           </a:bodyPr>
           <a:lstStyle>
             <a:lvl1pPr algn="ctr">
-              <a:defRPr sz="8000" b="0">
+              <a:defRPr sz="8000" b="1">
                 <a:solidFill>
                   <a:srgbClr val="6EC173"/>
                 </a:solidFill>
@@ -3947,7 +3962,7 @@
     </p:spTree>
     <p:extLst>
       <p:ext uri="{BB962C8B-B14F-4D97-AF65-F5344CB8AC3E}">
-        <p14:creationId xmlns:p14="http://schemas.microsoft.com/office/powerpoint/2010/main" val="3007288137"/>
+        <p14:creationId xmlns:p14="http://schemas.microsoft.com/office/powerpoint/2010/main" val="1065615894"/>
       </p:ext>
     </p:extLst>
   </p:cSld>
@@ -4054,7 +4069,7 @@
           <a:p>
             <a:fld id="{3C9CE3CE-253F-4F9D-BA15-C226C8D8501E}" type="datetime6">
               <a:rPr lang="ko-KR" altLang="en-US" smtClean="0"/>
-              <a:t>2023년 10월</a:t>
+              <a:t>2024년 8월</a:t>
             </a:fld>
             <a:endParaRPr lang="ko-KR" altLang="en-US"/>
           </a:p>
@@ -4143,7 +4158,11 @@
           <a:bodyPr vert="horz" lIns="91440" tIns="45720" rIns="91440" bIns="45720" rtlCol="0" anchor="ctr">
             <a:normAutofit/>
           </a:bodyPr>
-          <a:lstStyle/>
+          <a:lstStyle>
+            <a:lvl1pPr>
+              <a:defRPr b="1"/>
+            </a:lvl1pPr>
+          </a:lstStyle>
           <a:p>
             <a:r>
               <a:rPr lang="ko-KR" altLang="en-US" dirty="0"/>
@@ -4155,7 +4174,7 @@
     </p:spTree>
     <p:extLst>
       <p:ext uri="{BB962C8B-B14F-4D97-AF65-F5344CB8AC3E}">
-        <p14:creationId xmlns:p14="http://schemas.microsoft.com/office/powerpoint/2010/main" val="1271528127"/>
+        <p14:creationId xmlns:p14="http://schemas.microsoft.com/office/powerpoint/2010/main" val="764053945"/>
       </p:ext>
     </p:extLst>
   </p:cSld>
@@ -4367,7 +4386,7 @@
           <a:p>
             <a:fld id="{BE5A7087-D460-46DD-B430-F8D9B9677D08}" type="datetime6">
               <a:rPr lang="ko-KR" altLang="en-US" smtClean="0"/>
-              <a:t>2023년 10월</a:t>
+              <a:t>2024년 8월</a:t>
             </a:fld>
             <a:endParaRPr lang="ko-KR" altLang="en-US"/>
           </a:p>
@@ -4430,7 +4449,7 @@
     </p:spTree>
     <p:extLst>
       <p:ext uri="{BB962C8B-B14F-4D97-AF65-F5344CB8AC3E}">
-        <p14:creationId xmlns:p14="http://schemas.microsoft.com/office/powerpoint/2010/main" val="2308210370"/>
+        <p14:creationId xmlns:p14="http://schemas.microsoft.com/office/powerpoint/2010/main" val="2935509765"/>
       </p:ext>
     </p:extLst>
   </p:cSld>
@@ -4476,10 +4495,14 @@
         <p:spPr/>
         <p:txBody>
           <a:bodyPr/>
-          <a:lstStyle/>
-          <a:p>
-            <a:r>
-              <a:rPr lang="ko-KR" altLang="en-US"/>
+          <a:lstStyle>
+            <a:lvl1pPr>
+              <a:defRPr b="1"/>
+            </a:lvl1pPr>
+          </a:lstStyle>
+          <a:p>
+            <a:r>
+              <a:rPr lang="ko-KR" altLang="en-US" dirty="0"/>
               <a:t>마스터 제목 스타일 편집</a:t>
             </a:r>
           </a:p>
@@ -4632,7 +4655,7 @@
           <a:p>
             <a:fld id="{0581BA25-D675-4234-A003-8449BDEEF18E}" type="datetime6">
               <a:rPr lang="ko-KR" altLang="en-US" smtClean="0"/>
-              <a:t>2023년 10월</a:t>
+              <a:t>2024년 8월</a:t>
             </a:fld>
             <a:endParaRPr lang="ko-KR" altLang="en-US"/>
           </a:p>
@@ -4695,7 +4718,7 @@
     </p:spTree>
     <p:extLst>
       <p:ext uri="{BB962C8B-B14F-4D97-AF65-F5344CB8AC3E}">
-        <p14:creationId xmlns:p14="http://schemas.microsoft.com/office/powerpoint/2010/main" val="3553551868"/>
+        <p14:creationId xmlns:p14="http://schemas.microsoft.com/office/powerpoint/2010/main" val="4289534"/>
       </p:ext>
     </p:extLst>
   </p:cSld>
@@ -4746,10 +4769,14 @@
         </p:spPr>
         <p:txBody>
           <a:bodyPr/>
-          <a:lstStyle/>
-          <a:p>
-            <a:r>
-              <a:rPr lang="ko-KR" altLang="en-US"/>
+          <a:lstStyle>
+            <a:lvl1pPr>
+              <a:defRPr b="1"/>
+            </a:lvl1pPr>
+          </a:lstStyle>
+          <a:p>
+            <a:r>
+              <a:rPr lang="ko-KR" altLang="en-US" dirty="0"/>
               <a:t>마스터 제목 스타일 편집</a:t>
             </a:r>
           </a:p>
@@ -5044,7 +5071,7 @@
           <a:p>
             <a:fld id="{26155C29-A87F-46F0-A24C-6C9F0A4BF6AA}" type="datetime6">
               <a:rPr lang="ko-KR" altLang="en-US" smtClean="0"/>
-              <a:t>2023년 10월</a:t>
+              <a:t>2024년 8월</a:t>
             </a:fld>
             <a:endParaRPr lang="ko-KR" altLang="en-US"/>
           </a:p>
@@ -5107,7 +5134,7 @@
     </p:spTree>
     <p:extLst>
       <p:ext uri="{BB962C8B-B14F-4D97-AF65-F5344CB8AC3E}">
-        <p14:creationId xmlns:p14="http://schemas.microsoft.com/office/powerpoint/2010/main" val="3668274958"/>
+        <p14:creationId xmlns:p14="http://schemas.microsoft.com/office/powerpoint/2010/main" val="1314157266"/>
       </p:ext>
     </p:extLst>
   </p:cSld>
@@ -5153,10 +5180,14 @@
         <p:spPr/>
         <p:txBody>
           <a:bodyPr/>
-          <a:lstStyle/>
-          <a:p>
-            <a:r>
-              <a:rPr lang="ko-KR" altLang="en-US"/>
+          <a:lstStyle>
+            <a:lvl1pPr>
+              <a:defRPr b="1"/>
+            </a:lvl1pPr>
+          </a:lstStyle>
+          <a:p>
+            <a:r>
+              <a:rPr lang="ko-KR" altLang="en-US" dirty="0"/>
               <a:t>마스터 제목 스타일 편집</a:t>
             </a:r>
           </a:p>
@@ -5185,7 +5216,7 @@
           <a:p>
             <a:fld id="{DD2EDD62-8757-43DB-BAE0-460422B548EA}" type="datetime6">
               <a:rPr lang="ko-KR" altLang="en-US" smtClean="0"/>
-              <a:t>2023년 10월</a:t>
+              <a:t>2024년 8월</a:t>
             </a:fld>
             <a:endParaRPr lang="ko-KR" altLang="en-US"/>
           </a:p>
@@ -5248,7 +5279,7 @@
     </p:spTree>
     <p:extLst>
       <p:ext uri="{BB962C8B-B14F-4D97-AF65-F5344CB8AC3E}">
-        <p14:creationId xmlns:p14="http://schemas.microsoft.com/office/powerpoint/2010/main" val="89082187"/>
+        <p14:creationId xmlns:p14="http://schemas.microsoft.com/office/powerpoint/2010/main" val="2557258892"/>
       </p:ext>
     </p:extLst>
   </p:cSld>
@@ -5298,7 +5329,7 @@
           <a:p>
             <a:fld id="{DC6A871B-4800-495F-AC75-93D44C7DEBA5}" type="datetime6">
               <a:rPr lang="ko-KR" altLang="en-US" smtClean="0"/>
-              <a:t>2023년 10월</a:t>
+              <a:t>2024년 8월</a:t>
             </a:fld>
             <a:endParaRPr lang="ko-KR" altLang="en-US"/>
           </a:p>
@@ -5361,7 +5392,7 @@
     </p:spTree>
     <p:extLst>
       <p:ext uri="{BB962C8B-B14F-4D97-AF65-F5344CB8AC3E}">
-        <p14:creationId xmlns:p14="http://schemas.microsoft.com/office/powerpoint/2010/main" val="2200451853"/>
+        <p14:creationId xmlns:p14="http://schemas.microsoft.com/office/powerpoint/2010/main" val="1432982871"/>
       </p:ext>
     </p:extLst>
   </p:cSld>
@@ -5414,12 +5445,12 @@
           <a:bodyPr anchor="b"/>
           <a:lstStyle>
             <a:lvl1pPr>
-              <a:defRPr sz="3200"/>
+              <a:defRPr sz="3200" b="1"/>
             </a:lvl1pPr>
           </a:lstStyle>
           <a:p>
             <a:r>
-              <a:rPr lang="ko-KR" altLang="en-US"/>
+              <a:rPr lang="ko-KR" altLang="en-US" dirty="0"/>
               <a:t>마스터 제목 스타일 편집</a:t>
             </a:r>
           </a:p>
@@ -5609,7 +5640,7 @@
           <a:p>
             <a:fld id="{59605888-30A6-49BB-95E2-DEAE4E5B09E9}" type="datetime6">
               <a:rPr lang="ko-KR" altLang="en-US" smtClean="0"/>
-              <a:t>2023년 10월</a:t>
+              <a:t>2024년 8월</a:t>
             </a:fld>
             <a:endParaRPr lang="ko-KR" altLang="en-US"/>
           </a:p>
@@ -5672,7 +5703,7 @@
     </p:spTree>
     <p:extLst>
       <p:ext uri="{BB962C8B-B14F-4D97-AF65-F5344CB8AC3E}">
-        <p14:creationId xmlns:p14="http://schemas.microsoft.com/office/powerpoint/2010/main" val="2739508309"/>
+        <p14:creationId xmlns:p14="http://schemas.microsoft.com/office/powerpoint/2010/main" val="13873694"/>
       </p:ext>
     </p:extLst>
   </p:cSld>
@@ -5775,35 +5806,35 @@
           <a:p>
             <a:pPr lvl="0"/>
             <a:r>
-              <a:rPr lang="ko-KR" altLang="en-US"/>
+              <a:rPr lang="ko-KR" altLang="en-US" dirty="0"/>
               <a:t>마스터 텍스트 스타일을 편집하려면 클릭</a:t>
             </a:r>
           </a:p>
           <a:p>
             <a:pPr lvl="1"/>
             <a:r>
-              <a:rPr lang="ko-KR" altLang="en-US"/>
+              <a:rPr lang="ko-KR" altLang="en-US" dirty="0"/>
               <a:t>두 번째 수준</a:t>
             </a:r>
           </a:p>
           <a:p>
             <a:pPr lvl="2"/>
             <a:r>
-              <a:rPr lang="ko-KR" altLang="en-US"/>
+              <a:rPr lang="ko-KR" altLang="en-US" dirty="0"/>
               <a:t>세 번째 수준</a:t>
             </a:r>
           </a:p>
           <a:p>
             <a:pPr lvl="3"/>
             <a:r>
-              <a:rPr lang="ko-KR" altLang="en-US"/>
+              <a:rPr lang="ko-KR" altLang="en-US" dirty="0"/>
               <a:t>네 번째 수준</a:t>
             </a:r>
           </a:p>
           <a:p>
             <a:pPr lvl="4"/>
             <a:r>
-              <a:rPr lang="ko-KR" altLang="en-US"/>
+              <a:rPr lang="ko-KR" altLang="en-US" dirty="0"/>
               <a:t>다섯 번째 수준</a:t>
             </a:r>
           </a:p>
@@ -5850,7 +5881,7 @@
           <a:p>
             <a:fld id="{8691C14A-5735-4A8B-B68B-DEC1DC2A3813}" type="datetime6">
               <a:rPr lang="ko-KR" altLang="en-US" smtClean="0"/>
-              <a:t>2023년 10월</a:t>
+              <a:t>2024년 8월</a:t>
             </a:fld>
             <a:endParaRPr lang="ko-KR" altLang="en-US"/>
           </a:p>
@@ -6002,10 +6033,10 @@
       </p:sp>
       <p:pic>
         <p:nvPicPr>
-          <p:cNvPr id="9" name="그림 8" descr="텍스트, 클립아트이(가) 표시된 사진&#10;&#10;자동 생성된 설명">
+          <p:cNvPr id="14" name="그림 13" descr="그래픽, 그래픽 디자인, 폰트, 원이(가) 표시된 사진&#10;&#10;자동 생성된 설명">
             <a:extLst>
               <a:ext uri="{FF2B5EF4-FFF2-40B4-BE49-F238E27FC236}">
-                <a16:creationId xmlns:a16="http://schemas.microsoft.com/office/drawing/2014/main" id="{CFFA81A6-6D9A-9C22-6A01-103FCC7108B8}"/>
+                <a16:creationId xmlns:a16="http://schemas.microsoft.com/office/drawing/2014/main" id="{0EB71D7B-83F1-1414-954A-8C79751B7793}"/>
               </a:ext>
             </a:extLst>
           </p:cNvPr>
@@ -6016,7 +6047,6 @@
         </p:nvPicPr>
         <p:blipFill>
           <a:blip r:embed="rId14" cstate="hqprint">
-            <a:alphaModFix/>
             <a:extLst>
               <a:ext uri="{28A0092B-C50C-407E-A947-70E740481C1C}">
                 <a14:useLocalDpi xmlns:a14="http://schemas.microsoft.com/office/drawing/2010/main" val="0"/>
@@ -6029,136 +6059,35 @@
         </p:blipFill>
         <p:spPr>
           <a:xfrm>
-            <a:off x="11044576" y="140110"/>
-            <a:ext cx="1026976" cy="205105"/>
+            <a:off x="10835681" y="96056"/>
+            <a:ext cx="1260000" cy="270857"/>
           </a:xfrm>
           <a:prstGeom prst="rect">
             <a:avLst/>
           </a:prstGeom>
         </p:spPr>
       </p:pic>
-      <p:sp>
-        <p:nvSpPr>
-          <p:cNvPr id="10" name="TextBox 9">
-            <a:extLst>
-              <a:ext uri="{FF2B5EF4-FFF2-40B4-BE49-F238E27FC236}">
-                <a16:creationId xmlns:a16="http://schemas.microsoft.com/office/drawing/2014/main" id="{2E8CEA0B-0194-B9A0-705F-CAB04B3523DA}"/>
-              </a:ext>
-            </a:extLst>
-          </p:cNvPr>
-          <p:cNvSpPr txBox="1"/>
-          <p:nvPr userDrawn="1"/>
-        </p:nvSpPr>
-        <p:spPr>
-          <a:xfrm>
-            <a:off x="10814758" y="104713"/>
-            <a:ext cx="227015" cy="307777"/>
-          </a:xfrm>
-          <a:prstGeom prst="rect">
-            <a:avLst/>
-          </a:prstGeom>
-          <a:noFill/>
-        </p:spPr>
-        <p:txBody>
-          <a:bodyPr wrap="square" rtlCol="0">
-            <a:spAutoFit/>
-          </a:bodyPr>
-          <a:lstStyle/>
-          <a:p>
-            <a:pPr algn="ctr"/>
-            <a:r>
-              <a:rPr lang="en-US" altLang="ko-KR" sz="1400" b="1" dirty="0">
-                <a:solidFill>
-                  <a:schemeClr val="tx1"/>
-                </a:solidFill>
-              </a:rPr>
-              <a:t>X</a:t>
-            </a:r>
-            <a:endParaRPr lang="ko-KR" altLang="en-US" sz="2000" b="1" dirty="0">
-              <a:solidFill>
-                <a:schemeClr val="tx1"/>
-              </a:solidFill>
-            </a:endParaRPr>
-          </a:p>
-        </p:txBody>
-      </p:sp>
-      <p:pic>
-        <p:nvPicPr>
-          <p:cNvPr id="11" name="Picture 4" descr="청년취업사관학교, 새싹(SeSAC) - YouTube">
-            <a:extLst>
-              <a:ext uri="{FF2B5EF4-FFF2-40B4-BE49-F238E27FC236}">
-                <a16:creationId xmlns:a16="http://schemas.microsoft.com/office/drawing/2014/main" id="{AD5D531A-42B5-6D12-7A47-FFEB75D29CB0}"/>
-              </a:ext>
-            </a:extLst>
-          </p:cNvPr>
-          <p:cNvPicPr>
-            <a:picLocks noChangeAspect="1" noChangeArrowheads="1"/>
-          </p:cNvPicPr>
-          <p:nvPr userDrawn="1"/>
-        </p:nvPicPr>
-        <p:blipFill>
-          <a:blip r:embed="rId15" cstate="hqprint">
-            <a:extLst>
-              <a:ext uri="{BEBA8EAE-BF5A-486C-A8C5-ECC9F3942E4B}">
-                <a14:imgProps xmlns:a14="http://schemas.microsoft.com/office/drawing/2010/main">
-                  <a14:imgLayer r:embed="rId16">
-                    <a14:imgEffect>
-                      <a14:backgroundRemoval t="10000" b="90000" l="10000" r="90000"/>
-                    </a14:imgEffect>
-                  </a14:imgLayer>
-                </a14:imgProps>
-              </a:ext>
-              <a:ext uri="{28A0092B-C50C-407E-A947-70E740481C1C}">
-                <a14:useLocalDpi xmlns:a14="http://schemas.microsoft.com/office/drawing/2010/main" val="0"/>
-              </a:ext>
-            </a:extLst>
-          </a:blip>
-          <a:srcRect/>
-          <a:stretch>
-            <a:fillRect/>
-          </a:stretch>
-        </p:blipFill>
-        <p:spPr bwMode="auto">
-          <a:xfrm>
-            <a:off x="10492653" y="54125"/>
-            <a:ext cx="371243" cy="371243"/>
-          </a:xfrm>
-          <a:prstGeom prst="rect">
-            <a:avLst/>
-          </a:prstGeom>
-          <a:noFill/>
-          <a:extLst>
-            <a:ext uri="{909E8E84-426E-40DD-AFC4-6F175D3DCCD1}">
-              <a14:hiddenFill xmlns:a14="http://schemas.microsoft.com/office/drawing/2010/main">
-                <a:solidFill>
-                  <a:srgbClr val="FFFFFF"/>
-                </a:solidFill>
-              </a14:hiddenFill>
-            </a:ext>
-          </a:extLst>
-        </p:spPr>
-      </p:pic>
     </p:spTree>
     <p:extLst>
       <p:ext uri="{BB962C8B-B14F-4D97-AF65-F5344CB8AC3E}">
-        <p14:creationId xmlns:p14="http://schemas.microsoft.com/office/powerpoint/2010/main" val="111291268"/>
+        <p14:creationId xmlns:p14="http://schemas.microsoft.com/office/powerpoint/2010/main" val="1407032663"/>
       </p:ext>
     </p:extLst>
   </p:cSld>
   <p:clrMap bg1="lt1" tx1="dk1" bg2="lt2" tx2="dk2" accent1="accent1" accent2="accent2" accent3="accent3" accent4="accent4" accent5="accent5" accent6="accent6" hlink="hlink" folHlink="folHlink"/>
   <p:sldLayoutIdLst>
-    <p:sldLayoutId id="2147483661" r:id="rId1"/>
-    <p:sldLayoutId id="2147483662" r:id="rId2"/>
-    <p:sldLayoutId id="2147483663" r:id="rId3"/>
-    <p:sldLayoutId id="2147483664" r:id="rId4"/>
-    <p:sldLayoutId id="2147483665" r:id="rId5"/>
-    <p:sldLayoutId id="2147483666" r:id="rId6"/>
-    <p:sldLayoutId id="2147483667" r:id="rId7"/>
-    <p:sldLayoutId id="2147483668" r:id="rId8"/>
-    <p:sldLayoutId id="2147483669" r:id="rId9"/>
-    <p:sldLayoutId id="2147483670" r:id="rId10"/>
-    <p:sldLayoutId id="2147483671" r:id="rId11"/>
-    <p:sldLayoutId id="2147483672" r:id="rId12"/>
+    <p:sldLayoutId id="2147483674" r:id="rId1"/>
+    <p:sldLayoutId id="2147483675" r:id="rId2"/>
+    <p:sldLayoutId id="2147483676" r:id="rId3"/>
+    <p:sldLayoutId id="2147483677" r:id="rId4"/>
+    <p:sldLayoutId id="2147483678" r:id="rId5"/>
+    <p:sldLayoutId id="2147483679" r:id="rId6"/>
+    <p:sldLayoutId id="2147483680" r:id="rId7"/>
+    <p:sldLayoutId id="2147483681" r:id="rId8"/>
+    <p:sldLayoutId id="2147483682" r:id="rId9"/>
+    <p:sldLayoutId id="2147483683" r:id="rId10"/>
+    <p:sldLayoutId id="2147483684" r:id="rId11"/>
+    <p:sldLayoutId id="2147483685" r:id="rId12"/>
   </p:sldLayoutIdLst>
   <p:hf hdr="0" ftr="0"/>
   <p:txStyles>
@@ -6171,7 +6100,7 @@
           <a:spcPct val="0"/>
         </a:spcBef>
         <a:buNone/>
-        <a:defRPr sz="4400" kern="1200">
+        <a:defRPr sz="4400" b="1" kern="1200">
           <a:solidFill>
             <a:schemeClr val="tx1"/>
           </a:solidFill>
@@ -6537,7 +6466,7 @@
           <a:p>
             <a:fld id="{4DA02FB7-A3D0-4BF4-B23F-90A4C3B73A56}" type="datetime6">
               <a:rPr lang="ko-KR" altLang="en-US" smtClean="0"/>
-              <a:t>2023년 10월</a:t>
+              <a:t>2024년 8월</a:t>
             </a:fld>
             <a:endParaRPr lang="ko-KR" altLang="en-US" dirty="0"/>
           </a:p>
@@ -7014,7 +6943,7 @@
           <a:p>
             <a:fld id="{3C9CE3CE-253F-4F9D-BA15-C226C8D8501E}" type="datetime6">
               <a:rPr lang="ko-KR" altLang="en-US" smtClean="0"/>
-              <a:t>2023년 10월</a:t>
+              <a:t>2024년 8월</a:t>
             </a:fld>
             <a:endParaRPr lang="ko-KR" altLang="en-US"/>
           </a:p>
@@ -7498,6 +7427,16 @@
             </a:endParaRPr>
           </a:p>
           <a:p>
+            <a:r>
+              <a:rPr lang="en-US" altLang="ko-KR" b="0" dirty="0">
+                <a:solidFill>
+                  <a:srgbClr val="A9B1D6"/>
+                </a:solidFill>
+                <a:effectLst/>
+                <a:latin typeface="Consolas" panose="020B0609020204030204" pitchFamily="49" charset="0"/>
+              </a:rPr>
+              <a:t/>
+            </a:r>
             <a:br>
               <a:rPr lang="en-US" altLang="ko-KR" b="0" dirty="0">
                 <a:solidFill>
@@ -10376,7 +10315,7 @@
           <a:p>
             <a:fld id="{0E19CB95-6D28-40F1-9DA3-1BAC5D4B5B4F}" type="datetime6">
               <a:rPr lang="ko-KR" altLang="en-US" smtClean="0"/>
-              <a:t>2023년 10월</a:t>
+              <a:t>2024년 8월</a:t>
             </a:fld>
             <a:endParaRPr lang="ko-KR" altLang="en-US"/>
           </a:p>
@@ -10491,7 +10430,7 @@
           <a:p>
             <a:fld id="{0E19CB95-6D28-40F1-9DA3-1BAC5D4B5B4F}" type="datetime6">
               <a:rPr lang="ko-KR" altLang="en-US" smtClean="0"/>
-              <a:t>2023년 10월</a:t>
+              <a:t>2024년 8월</a:t>
             </a:fld>
             <a:endParaRPr lang="ko-KR" altLang="en-US"/>
           </a:p>
@@ -11108,7 +11047,7 @@
           <a:p>
             <a:fld id="{0E19CB95-6D28-40F1-9DA3-1BAC5D4B5B4F}" type="datetime6">
               <a:rPr lang="ko-KR" altLang="en-US" smtClean="0"/>
-              <a:t>2023년 10월</a:t>
+              <a:t>2024년 8월</a:t>
             </a:fld>
             <a:endParaRPr lang="ko-KR" altLang="en-US"/>
           </a:p>
@@ -12178,6 +12117,13 @@
                 <a:ea typeface="메이플스토리" panose="02000300000000000000" pitchFamily="2" charset="-127"/>
               </a:rPr>
               <a:t>되는 것</a:t>
+            </a:r>
+            <a:r>
+              <a:rPr lang="en-US" altLang="ko-KR" dirty="0">
+                <a:latin typeface="메이플스토리" panose="02000300000000000000" pitchFamily="2" charset="-127"/>
+                <a:ea typeface="메이플스토리" panose="02000300000000000000" pitchFamily="2" charset="-127"/>
+              </a:rPr>
+              <a:t/>
             </a:r>
             <a:br>
               <a:rPr lang="en-US" altLang="ko-KR" dirty="0">
@@ -12575,7 +12521,7 @@
           <a:p>
             <a:fld id="{3C9CE3CE-253F-4F9D-BA15-C226C8D8501E}" type="datetime6">
               <a:rPr lang="ko-KR" altLang="en-US" smtClean="0"/>
-              <a:t>2023년 10월</a:t>
+              <a:t>2024년 8월</a:t>
             </a:fld>
             <a:endParaRPr lang="ko-KR" altLang="en-US"/>
           </a:p>
@@ -13810,7 +13756,7 @@
           <a:p>
             <a:fld id="{0E19CB95-6D28-40F1-9DA3-1BAC5D4B5B4F}" type="datetime6">
               <a:rPr lang="ko-KR" altLang="en-US" smtClean="0"/>
-              <a:t>2023년 10월</a:t>
+              <a:t>2024년 8월</a:t>
             </a:fld>
             <a:endParaRPr lang="ko-KR" altLang="en-US"/>
           </a:p>
@@ -14014,6 +13960,10 @@
             <a:r>
               <a:rPr lang="ko-KR" altLang="en-US" dirty="0"/>
               <a:t>에 따라 함수 전체 타입 설정 </a:t>
+            </a:r>
+            <a:r>
+              <a:rPr lang="en-US" altLang="ko-KR" dirty="0"/>
+              <a:t/>
             </a:r>
             <a:br>
               <a:rPr lang="en-US" altLang="ko-KR" dirty="0"/>
@@ -16119,7 +16069,7 @@
           <a:p>
             <a:fld id="{3C9CE3CE-253F-4F9D-BA15-C226C8D8501E}" type="datetime6">
               <a:rPr lang="ko-KR" altLang="en-US" smtClean="0"/>
-              <a:t>2023년 10월</a:t>
+              <a:t>2024년 8월</a:t>
             </a:fld>
             <a:endParaRPr lang="ko-KR" altLang="en-US"/>
           </a:p>
@@ -16205,8 +16155,8 @@
         </p:nvSpPr>
         <p:spPr>
           <a:xfrm>
-            <a:off x="2023730" y="2695361"/>
-            <a:ext cx="8144540" cy="369332"/>
+            <a:off x="1355464" y="2695361"/>
+            <a:ext cx="9542032" cy="369332"/>
           </a:xfrm>
           <a:prstGeom prst="rect">
             <a:avLst/>
@@ -18149,7 +18099,7 @@
           <a:p>
             <a:fld id="{0E19CB95-6D28-40F1-9DA3-1BAC5D4B5B4F}" type="datetime6">
               <a:rPr lang="ko-KR" altLang="en-US" smtClean="0"/>
-              <a:t>2023년 10월</a:t>
+              <a:t>2024년 8월</a:t>
             </a:fld>
             <a:endParaRPr lang="ko-KR" altLang="en-US"/>
           </a:p>
@@ -20237,7 +20187,12 @@
             <p:ph idx="1"/>
           </p:nvPr>
         </p:nvSpPr>
-        <p:spPr/>
+        <p:spPr>
+          <a:xfrm>
+            <a:off x="838200" y="1825625"/>
+            <a:ext cx="10906760" cy="4351338"/>
+          </a:xfrm>
+        </p:spPr>
         <p:txBody>
           <a:bodyPr/>
           <a:lstStyle/>
@@ -20303,12 +20258,13 @@
               <a:rPr lang="en-US" altLang="ko-KR" dirty="0"/>
               <a:t>, </a:t>
             </a:r>
-            <a:br>
-              <a:rPr lang="en-US" altLang="ko-KR" dirty="0"/>
-            </a:br>
+            <a:r>
+              <a:rPr lang="ko-KR" altLang="en-US" dirty="0" smtClean="0"/>
+              <a:t>의도와 </a:t>
+            </a:r>
             <a:r>
               <a:rPr lang="ko-KR" altLang="en-US" dirty="0"/>
-              <a:t>의도와 다른 방식으로 쓰이지 않도록 방지</a:t>
+              <a:t>다른 방식으로 쓰이지 않도록 방지</a:t>
             </a:r>
             <a:endParaRPr lang="en-US" altLang="ko-KR" dirty="0"/>
           </a:p>
@@ -20324,7 +20280,35 @@
                   <a:schemeClr val="accent1"/>
                 </a:solidFill>
               </a:rPr>
-              <a:t>정적 파일 언어</a:t>
+              <a:t>정적 </a:t>
+            </a:r>
+            <a:r>
+              <a:rPr lang="ko-KR" altLang="en-US" dirty="0" smtClean="0">
+                <a:solidFill>
+                  <a:schemeClr val="accent1"/>
+                </a:solidFill>
+              </a:rPr>
+              <a:t>타입</a:t>
+            </a:r>
+            <a:r>
+              <a:rPr lang="ko-KR" altLang="en-US" dirty="0" smtClean="0">
+                <a:solidFill>
+                  <a:schemeClr val="accent1"/>
+                </a:solidFill>
+              </a:rPr>
+              <a:t> </a:t>
+            </a:r>
+            <a:r>
+              <a:rPr lang="ko-KR" altLang="en-US" dirty="0">
+                <a:solidFill>
+                  <a:schemeClr val="accent1"/>
+                </a:solidFill>
+              </a:rPr>
+              <a:t>언어</a:t>
+            </a:r>
+            <a:r>
+              <a:rPr lang="en-US" altLang="ko-KR" dirty="0"/>
+              <a:t/>
             </a:r>
             <a:br>
               <a:rPr lang="en-US" altLang="ko-KR" dirty="0"/>
@@ -20566,7 +20550,7 @@
           <a:p>
             <a:fld id="{3C9CE3CE-253F-4F9D-BA15-C226C8D8501E}" type="datetime6">
               <a:rPr lang="ko-KR" altLang="en-US" smtClean="0"/>
-              <a:t>2023년 10월</a:t>
+              <a:t>2024년 8월</a:t>
             </a:fld>
             <a:endParaRPr lang="ko-KR" altLang="en-US"/>
           </a:p>
@@ -20819,7 +20803,7 @@
           <a:p>
             <a:fld id="{3C9CE3CE-253F-4F9D-BA15-C226C8D8501E}" type="datetime6">
               <a:rPr lang="ko-KR" altLang="en-US" smtClean="0"/>
-              <a:t>2023년 10월</a:t>
+              <a:t>2024년 8월</a:t>
             </a:fld>
             <a:endParaRPr lang="ko-KR" altLang="en-US"/>
           </a:p>
@@ -20928,7 +20912,7 @@
         </p:blipFill>
         <p:spPr bwMode="auto">
           <a:xfrm>
-            <a:off x="7568167" y="1981949"/>
+            <a:off x="8370807" y="1981949"/>
             <a:ext cx="3252233" cy="382615"/>
           </a:xfrm>
           <a:prstGeom prst="rect">
@@ -22031,7 +22015,7 @@
         <p:spPr/>
         <p:txBody>
           <a:bodyPr>
-            <a:normAutofit/>
+            <a:normAutofit lnSpcReduction="10000"/>
           </a:bodyPr>
           <a:lstStyle/>
           <a:p>
@@ -22704,7 +22688,7 @@
           <a:p>
             <a:fld id="{3C9CE3CE-253F-4F9D-BA15-C226C8D8501E}" type="datetime6">
               <a:rPr lang="ko-KR" altLang="en-US" smtClean="0"/>
-              <a:t>2023년 10월</a:t>
+              <a:t>2024년 8월</a:t>
             </a:fld>
             <a:endParaRPr lang="ko-KR" altLang="en-US"/>
           </a:p>
@@ -22785,7 +22769,7 @@
 </file>
 
 <file path=ppt/theme/theme1.xml><?xml version="1.0" encoding="utf-8"?>
-<a:theme xmlns:a="http://schemas.openxmlformats.org/drawingml/2006/main" name="2_Office 테마">
+<a:theme xmlns:a="http://schemas.openxmlformats.org/drawingml/2006/main" name="3_Office 테마">
   <a:themeElements>
     <a:clrScheme name="코딩온_새싹">
       <a:dk1>
@@ -22825,15 +22809,15 @@
         <a:srgbClr val="954F72"/>
       </a:folHlink>
     </a:clrScheme>
-    <a:fontScheme name="코딩온">
+    <a:fontScheme name="Pretendard GOV">
       <a:majorFont>
-        <a:latin typeface="메이플스토리"/>
-        <a:ea typeface="메이플스토리"/>
+        <a:latin typeface="Pretendard GOV"/>
+        <a:ea typeface="Pretendard GOV"/>
         <a:cs typeface=""/>
       </a:majorFont>
       <a:minorFont>
-        <a:latin typeface="메이플스토리"/>
-        <a:ea typeface="메이플스토리"/>
+        <a:latin typeface="Pretendard GOV"/>
+        <a:ea typeface="Pretendard GOV"/>
         <a:cs typeface=""/>
       </a:minorFont>
     </a:fontScheme>

</xml_diff>